<commit_message>
fix: use the resolving DOI for the ConCap paper
The SaTML'26 conference DOI 10.1109/SaTML68715.2026.00051 is not yet
registered and returns 404 from doi.org. Cite the arXiv DOI instead,
which resolves to the same paper.

All seventeen DOIs were checked against doi.org content negotiation;
titles, first authors and years match the survey rows.
</commit_message>
<xml_diff>
--- a/Project_Network_Anomaly_Detection.pptx
+++ b/Project_Network_Anomaly_Detection.pptx
@@ -16669,7 +16669,7 @@
                           <a:effectLst/>
                           <a:latin typeface="Times New Roman" panose="02020603050405020304" pitchFamily="18" charset="0"/>
                         </a:rPr>
-                        <a:t xml:space="preserve">IEEE SaTML</a:t>
+                        <a:t xml:space="preserve">arXiv (IEEE SaTML'26)</a:t>
                       </a:r>
                       <a:endParaRPr lang="en-IN" sz="1000" b="0" i="0" u="none" strike="noStrike">
                         <a:solidFill>
@@ -17138,7 +17138,7 @@
                           <a:effectLst/>
                           <a:latin typeface="Calibri" panose="020F0502020204030204" pitchFamily="34" charset="0"/>
                         </a:rPr>
-                        <a:t xml:space="preserve">10.1109/SaTML68715.2026.00051</a:t>
+                        <a:t xml:space="preserve">10.48550/arXiv.2509.16038</a:t>
                       </a:r>
                       <a:endParaRPr lang="en-IN" sz="1000" b="0" i="0" u="none" strike="noStrike" dirty="0">
                         <a:solidFill>

</xml_diff>